<commit_message>
docs(dac): introduce LoDA-SA distance-aware narrative
</commit_message>
<xml_diff>
--- a/agent_doc/advice/dac_manuscript/presentation/TwoLevel_UserEdited_20261014.pptx
+++ b/agent_doc/advice/dac_manuscript/presentation/TwoLevel_UserEdited_20261014.pptx
@@ -2328,29 +2328,7 @@
                 <a:ea typeface="Noto Sans CJK SC"/>
                 <a:cs typeface="Noto Sans CJK SC"/>
               </a:rPr>
-              <a:t>子空间</a:t>
-            </a:r>
-            <a:r>
-              <a:rPr lang="zh-CN" altLang="en-US" sz="3600" b="1" dirty="0">
-                <a:solidFill>
-                  <a:srgbClr val="FFFFFF"/>
-                </a:solidFill>
-                <a:latin typeface="Noto Sans CJK SC"/>
-                <a:ea typeface="Noto Sans CJK SC"/>
-                <a:cs typeface="Noto Sans CJK SC"/>
-              </a:rPr>
-              <a:t>下</a:t>
-            </a:r>
-            <a:r>
-              <a:rPr sz="3600" b="1" dirty="0" err="1">
-                <a:solidFill>
-                  <a:srgbClr val="FFFFFF"/>
-                </a:solidFill>
-                <a:latin typeface="Noto Sans CJK SC"/>
-                <a:ea typeface="Noto Sans CJK SC"/>
-                <a:cs typeface="Noto Sans CJK SC"/>
-              </a:rPr>
-              <a:t>的近远两级注意力</a:t>
+              <a:t>LoDA-SA：低频距离感知稀疏注意力</a:t>
             </a:r>
             <a:endParaRPr sz="3600" b="1" dirty="0">
               <a:solidFill>
@@ -2531,7 +2509,7 @@
                 <a:ea typeface="Noto Sans CJK SC"/>
                 <a:cs typeface="Noto Sans CJK SC"/>
               </a:rPr>
-              <a:t>共享低维索引，保留原维注意力</a:t>
+              <a:t>Low-Frequency Distance-Aware Sparse Attention</a:t>
             </a:r>
           </a:p>
         </p:txBody>
@@ -3096,7 +3074,7 @@
                 <a:ea typeface="Noto Sans CJK SC"/>
                 <a:cs typeface="Noto Sans CJK SC"/>
               </a:rPr>
-              <a:t>共享低频坐标与区域页配额</a:t>
+              <a:t>距离区域候选准入 → 共享低频评分 → 统一 L2</a:t>
             </a:r>
           </a:p>
         </p:txBody>
@@ -3305,7 +3283,7 @@
                 <a:ea typeface="Noto Sans CJK SC"/>
                 <a:cs typeface="Noto Sans CJK SC"/>
               </a:rPr>
-              <a:t>GQA：组共享选择，各查询头独立计算注意力</a:t>
+              <a:t>LoDA-SA：统一 L2 与原维注意力</a:t>
             </a:r>
           </a:p>
         </p:txBody>
@@ -8044,7 +8022,7 @@
       </p:sp>
       <p:pic xmlns:a="http://schemas.openxmlformats.org/drawingml/2006/main" xmlns:r="http://schemas.openxmlformats.org/officeDocument/2006/relationships">
         <p:nvPicPr>
-          <p:cNvPr id="14" name="Picture 13" descr="image.png"/>
+          <p:cNvPr id="16" name="Picture 15" descr="image.png"/>
           <p:cNvPicPr>
             <a:picLocks noChangeAspect="1"/>
           </p:cNvPicPr>
@@ -9534,7 +9512,7 @@
       </p:sp>
       <p:pic>
         <p:nvPicPr>
-          <p:cNvPr id="13" name="Picture 12" descr="image.png"/>
+          <p:cNvPr id="15" name="Picture 14" descr="image.png"/>
           <p:cNvPicPr>
             <a:picLocks noChangeAspect="1"/>
           </p:cNvPicPr>
@@ -9717,7 +9695,7 @@
                 <a:ea typeface="Noto Sans CJK SC"/>
                 <a:cs typeface="Noto Sans CJK SC"/>
               </a:rPr>
-              <a:t>评分表示、区域访问与执行成本的取舍</a:t>
+              <a:t>LoDA-SA：距离准入、共享评分与完整请求成本</a:t>
             </a:r>
           </a:p>
         </p:txBody>
@@ -10797,7 +10775,7 @@
                 <a:ea typeface="Noto Sans CJK SC"/>
                 <a:cs typeface="Noto Sans CJK SC"/>
               </a:rPr>
-              <a:t>固定词元预算下：候选访问与选择成本</a:t>
+              <a:t>LoDA-SA：有限预算下保留不同距离的候选入口</a:t>
             </a:r>
             <a:endParaRPr sz="3225" b="1">
               <a:solidFill>
@@ -10939,19 +10917,8 @@
                 <a:ea typeface="Noto Sans CJK SC"/>
                 <a:cs typeface="Noto Sans CJK SC"/>
               </a:rPr>
-              <a:t>均值与极值刻画不同评分目标，页注意力和另作参照。
-全局TopK不提供区域容量保证。</a:t>
-            </a:r>
-            <a:r>
-              <a:rPr sz="2175" b="0">
-                <a:solidFill>
-                  <a:srgbClr val="183146"/>
-                </a:solidFill>
-                <a:latin typeface="Noto Sans CJK SC"/>
-                <a:ea typeface="Noto Sans CJK SC"/>
-                <a:cs typeface="Noto Sans CJK SC"/>
-              </a:rPr>
-              <a:t/>
+              <a:t>全局排名不预留位置区域入口；先明确候选覆盖，再控制筛选成本。
+不假设近处总重要，也不假设注意力随距离单调衰减。</a:t>
             </a:r>
           </a:p>
         </p:txBody>
@@ -11085,7 +11052,7 @@
                 <a:ea typeface="Noto Sans CJK SC"/>
                 <a:cs typeface="Noto Sans CJK SC"/>
               </a:rPr>
-              <a:t>共享32个低频RoPE坐标；nl定义近区范围、nb预留近区页；合并候选统一L2竞争，最终原维注意力。</a:t>
+              <a:t>nl定义近区、nb预留L1近区页；两级共享32个低频RoPE坐标；合并候选统一L2，最终原维Q/K/V。</a:t>
             </a:r>
           </a:p>
         </p:txBody>
@@ -11631,7 +11598,7 @@
       </p:sp>
       <p:pic>
         <p:nvPicPr>
-          <p:cNvPr id="110" name="Picture 109" descr="image.png"/>
+          <p:cNvPr id="112" name="Picture 111" descr="image.png"/>
           <p:cNvPicPr>
             <a:picLocks noChangeAspect="1"/>
           </p:cNvPicPr>
@@ -13098,7 +13065,7 @@
                 <a:ea typeface="Noto Sans CJK SC"/>
                 <a:cs typeface="Noto Sans CJK SC"/>
               </a:rPr>
-              <a:t>两项核心机制，一个可选扩展</a:t>
+              <a:t>LoDA-SA：先说明距离策略，再说明共享评分</a:t>
             </a:r>
           </a:p>
         </p:txBody>
@@ -13232,7 +13199,7 @@
                 <ns0:ea typeface="Noto Sans CJK SC"/>
                 <ns0:cs typeface="Noto Sans CJK SC"/>
               </ns0:rPr>
-              <ns0:t>共享低频RoPE坐标</ns0:t>
+              <ns0:t>距离区域与页预算</ns0:t>
             </ns0:r>
           </ns0:p>
         </p:txBody>
@@ -13299,33 +13266,10 @@
                 <ns1:ea typeface="Noto Sans CJK SC"/>
                 <ns1:cs typeface="Noto Sans CJK SC"/>
               </ns1:rPr>
-              <ns1:t>同层同KV头的16完整旋转对</ns1:t>
+              <ns1:t>nl 指定近区范围；nb 预留近区页
+远区获得剩余 L1 页预算</ns1:t>
             </ns1:r>
           </ns1:p>
-          <ns2:p xmlns:ns2="http://schemas.openxmlformats.org/drawingml/2006/main">
-            <ns2:pPr>
-              <ns2:buNone/>
-              <ns2:defRPr sz="2025" b="0">
-                <ns2:solidFill>
-                  <ns2:srgbClr val="536574"/>
-                </ns2:solidFill>
-                <ns2:latin typeface="Noto Sans CJK SC"/>
-                <ns2:ea typeface="Noto Sans CJK SC"/>
-                <ns2:cs typeface="Noto Sans CJK SC"/>
-              </ns2:defRPr>
-            </ns2:pPr>
-            <ns2:r>
-              <ns2:rPr sz="2025" b="0">
-                <ns2:solidFill>
-                  <ns2:srgbClr val="536574"/>
-                </ns2:solidFill>
-                <ns2:latin typeface="Noto Sans CJK SC"/>
-                <ns2:ea typeface="Noto Sans CJK SC"/>
-                <ns2:cs typeface="Noto Sans CJK SC"/>
-              </ns2:rPr>
-              <ns2:t>近区 / 远区、L1 / L2共用坐标</ns2:t>
-            </ns2:r>
-          </ns2:p>
         </p:txBody>
       </p:sp>
       <p:sp>
@@ -13390,7 +13334,7 @@
                 <a:ea typeface="Noto Sans CJK SC"/>
                 <a:cs typeface="Noto Sans CJK SC"/>
               </a:rPr>
-              <a:t>共享坐标映射，不要求共享物理缓冲区</a:t>
+              <a:t>页准入不保证最终区域份额</a:t>
             </a:r>
           </a:p>
         </p:txBody>
@@ -13561,7 +13505,7 @@
                 <a:ea typeface="Noto Sans CJK SC"/>
                 <a:cs typeface="Noto Sans CJK SC"/>
               </a:rPr>
-              <a:t>显式近区范围与页预算</a:t>
+              <a:t>共享低频 RoPE 评分</a:t>
             </a:r>
           </a:p>
         </p:txBody>
@@ -13628,8 +13572,8 @@
                 <a:ea typeface="Noto Sans CJK SC"/>
                 <a:cs typeface="Noto Sans CJK SC"/>
               </a:rPr>
-              <a:t>nl 指定近区范围；nb 预留近区页
-合并候选统一 L2；最终原维 Q / K / V</a:t>
+              <a:t>16完整旋转对，两级共用
+合并候选统一L2，最终原维注意力</a:t>
             </a:r>
           </a:p>
         </p:txBody>
@@ -13696,7 +13640,7 @@
                 <a:ea typeface="Noto Sans CJK SC"/>
                 <a:cs typeface="Noto Sans CJK SC"/>
               </a:rPr>
-              <a:t>页准入不保证最终区域份额</a:t>
+              <a:t>执行仍先准备表示，再进行区域选择</a:t>
             </a:r>
           </a:p>
         </p:txBody>
@@ -14166,7 +14110,7 @@
                 <a:latin typeface="Noto Sans CJK SC"/>
                 <a:ea typeface="Noto Sans CJK SC"/>
               </a:rPr>
-              <a:t>总架构：共享索引与原维注意力</a:t>
+              <a:t>LoDA-SA：同一时间序列上的两级筛选</a:t>
             </a:r>
           </a:p>
         </p:txBody>
@@ -14279,7 +14223,7 @@
                 </a:solidFill>
                 <a:latin typeface="Noto Sans CJK SC"/>
               </a:rPr>
-              <a:t>同一时间顺序 · nl 确定近区范围</a:t>
+              <a:t>LoDA-SA · 同一时间顺序，nl 确定近区</a:t>
             </a:r>
           </a:p>
         </p:txBody>
@@ -18560,7 +18504,7 @@
                 <a:latin typeface="Noto Sans CJK SC"/>
                 <a:ea typeface="Noto Sans CJK SC"/>
               </a:rPr>
-              <a:t>低频子空间：16个完整旋转对，共32维</a:t>
+              <a:t>LoDA-SA：两级共享完整低频 RoPE 对</a:t>
             </a:r>
             <a:endParaRPr lang="zh-CN" sz="3000"/>
           </a:p>
@@ -38768,7 +38712,7 @@
                 <a:latin typeface="Noto Sans CJK SC"/>
                 <a:ea typeface="Noto Sans CJK SC"/>
               </a:rPr>
-              <a:t>nl / nb：区域页准入，统一词元竞争</a:t>
+              <a:t>LoDA-SA：nl / nb 页准入与统一词元竞争</a:t>
             </a:r>
           </a:p>
         </p:txBody>

</xml_diff>

<commit_message>
docs(dac): bound grid claims and align validated deliverables
</commit_message>
<xml_diff>
--- a/agent_doc/advice/dac_manuscript/presentation/TwoLevel_UserEdited_20261014.pptx
+++ b/agent_doc/advice/dac_manuscript/presentation/TwoLevel_UserEdited_20261014.pptx
@@ -7355,7 +7355,7 @@
                 <a:ea typeface="Noto Sans CJK SC"/>
                 <a:cs typeface="Noto Sans CJK SC"/>
               </a:rPr>
-              <a:t>近远检索</a:t>
+              <a:t>归档网格：描述性结果</a:t>
             </a:r>
             <a:endParaRPr sz="2400"/>
           </a:p>
@@ -7406,7 +7406,7 @@
                 <a:ea typeface="Noto Sans CJK SC"/>
                 <a:cs typeface="Noto Sans CJK SC"/>
               </a:rPr>
-              <a:t>26.09 → 47.91</a:t>
+              <a:t>48.264 / 47.462</a:t>
             </a:r>
             <a:endParaRPr sz="3000"/>
           </a:p>
@@ -7457,41 +7457,12 @@
                 <ns5:ea typeface="Noto Sans CJK SC"/>
                 <ns5:cs typeface="Noto Sans CJK SC"/>
               </ns5:rPr>
-              <ns5:t>仅保护词元与中间历史检索比较，</ns5:t>
+              <ns5:t>免配额 / 单池对照
+同几何配额448：48.668
+69比较、17几何：均差+0.040
+不证明无效应或当前配置质量</ns5:t>
             </ns5:r>
           </ns5:p>
-          <ns6:p xmlns:ns6="http://schemas.openxmlformats.org/drawingml/2006/main">
-            <ns6:pPr algn="l">
-              <ns6:buNone/>
-            </ns6:pPr>
-            <ns6:r>
-              <ns6:rPr sz="1875" b="0">
-                <ns6:solidFill>
-                  <ns6:srgbClr val="193247"/>
-                </ns6:solidFill>
-                <ns6:latin typeface="Noto Sans CJK SC"/>
-                <ns6:ea typeface="Noto Sans CJK SC"/>
-                <ns6:cs typeface="Noto Sans CJK SC"/>
-              </ns6:rPr>
-              <ns6:t>预算256→1024，</ns6:t>
-            </ns6:r>
-          </ns6:p>
-          <ns7:p xmlns:ns7="http://schemas.openxmlformats.org/drawingml/2006/main">
-            <ns7:pPr algn="l">
-              <ns7:buNone/>
-            </ns7:pPr>
-            <ns7:r>
-              <ns7:rPr sz="1875" b="0">
-                <ns7:solidFill>
-                  <ns7:srgbClr val="193247"/>
-                </ns7:solidFill>
-                <ns7:latin typeface="Noto Sans CJK SC"/>
-                <ns7:ea typeface="Noto Sans CJK SC"/>
-                <ns7:cs typeface="Noto Sans CJK SC"/>
-              </ns7:rPr>
-              <ns7:t>未隔离区域分配效应。</ns7:t>
-            </ns7:r>
-          </ns7:p>
         </p:txBody>
       </p:sp>
       <p:sp>
@@ -8022,7 +7993,7 @@
       </p:sp>
       <p:pic xmlns:a="http://schemas.openxmlformats.org/drawingml/2006/main" xmlns:r="http://schemas.openxmlformats.org/officeDocument/2006/relationships">
         <p:nvPicPr>
-          <p:cNvPr id="16" name="Picture 15" descr="image.png"/>
+          <p:cNvPr id="19" name="Picture 18" descr="image.png"/>
           <p:cNvPicPr>
             <a:picLocks noChangeAspect="1"/>
           </p:cNvPicPr>
@@ -9512,7 +9483,7 @@
       </p:sp>
       <p:pic>
         <p:nvPicPr>
-          <p:cNvPr id="15" name="Picture 14" descr="image.png"/>
+          <p:cNvPr id="18" name="Picture 17" descr="image.png"/>
           <p:cNvPicPr>
             <a:picLocks noChangeAspect="1"/>
           </p:cNvPicPr>
@@ -10432,8 +10403,8 @@
                 <ns6:ea typeface="Noto Sans CJK SC"/>
                 <ns6:cs typeface="Noto Sans CJK SC"/>
               </ns6:rPr>
-              <ns6:t>nb 控制候选页准入，不保证最终区域份额
-nl/nb统一L2仍缺匹配质量与完整请求成本</ns6:t>
+              <ns6:t>nb 控制候选准入，不保证最终区域份额
+网格均值不证明无配额效应；仍缺匹配质量—成本</ns6:t>
             </ns6:r>
           </ns6:p>
         </p:txBody>
@@ -11598,7 +11569,7 @@
       </p:sp>
       <p:pic>
         <p:nvPicPr>
-          <p:cNvPr id="112" name="Picture 111" descr="image.png"/>
+          <p:cNvPr id="115" name="Picture 114" descr="image.png"/>
           <p:cNvPicPr>
             <a:picLocks noChangeAspect="1"/>
           </p:cNvPicPr>

</xml_diff>